<commit_message>
change steering committee size to five total (#30)
* change steering committee size to four plus one

* update pptx graphic
</commit_message>
<xml_diff>
--- a/graphics/RSS-Governance-overview.pptx
+++ b/graphics/RSS-Governance-overview.pptx
@@ -302,7 +302,7 @@
           <a:p>
             <a:fld id="{5BCAD085-E8A6-8845-BD4E-CB4CCA059FC4}" type="datetimeFigureOut">
               <a:rPr lang="en-US" smtClean="0"/>
-              <a:t>8/6/26</a:t>
+              <a:t>9/17/26</a:t>
             </a:fld>
             <a:endParaRPr lang="en-US"/>
           </a:p>
@@ -470,7 +470,7 @@
           <a:p>
             <a:fld id="{5BCAD085-E8A6-8845-BD4E-CB4CCA059FC4}" type="datetimeFigureOut">
               <a:rPr lang="en-US" smtClean="0"/>
-              <a:t>8/6/26</a:t>
+              <a:t>9/17/26</a:t>
             </a:fld>
             <a:endParaRPr lang="en-US"/>
           </a:p>
@@ -648,7 +648,7 @@
           <a:p>
             <a:fld id="{5BCAD085-E8A6-8845-BD4E-CB4CCA059FC4}" type="datetimeFigureOut">
               <a:rPr lang="en-US" smtClean="0"/>
-              <a:t>8/6/26</a:t>
+              <a:t>9/17/26</a:t>
             </a:fld>
             <a:endParaRPr lang="en-US"/>
           </a:p>
@@ -816,7 +816,7 @@
           <a:p>
             <a:fld id="{5BCAD085-E8A6-8845-BD4E-CB4CCA059FC4}" type="datetimeFigureOut">
               <a:rPr lang="en-US" smtClean="0"/>
-              <a:t>8/6/26</a:t>
+              <a:t>9/17/26</a:t>
             </a:fld>
             <a:endParaRPr lang="en-US"/>
           </a:p>
@@ -1061,7 +1061,7 @@
           <a:p>
             <a:fld id="{5BCAD085-E8A6-8845-BD4E-CB4CCA059FC4}" type="datetimeFigureOut">
               <a:rPr lang="en-US" smtClean="0"/>
-              <a:t>8/6/26</a:t>
+              <a:t>9/17/26</a:t>
             </a:fld>
             <a:endParaRPr lang="en-US"/>
           </a:p>
@@ -1346,7 +1346,7 @@
           <a:p>
             <a:fld id="{5BCAD085-E8A6-8845-BD4E-CB4CCA059FC4}" type="datetimeFigureOut">
               <a:rPr lang="en-US" smtClean="0"/>
-              <a:t>8/6/26</a:t>
+              <a:t>9/17/26</a:t>
             </a:fld>
             <a:endParaRPr lang="en-US"/>
           </a:p>
@@ -1765,7 +1765,7 @@
           <a:p>
             <a:fld id="{5BCAD085-E8A6-8845-BD4E-CB4CCA059FC4}" type="datetimeFigureOut">
               <a:rPr lang="en-US" smtClean="0"/>
-              <a:t>8/6/26</a:t>
+              <a:t>9/17/26</a:t>
             </a:fld>
             <a:endParaRPr lang="en-US"/>
           </a:p>
@@ -1882,7 +1882,7 @@
           <a:p>
             <a:fld id="{5BCAD085-E8A6-8845-BD4E-CB4CCA059FC4}" type="datetimeFigureOut">
               <a:rPr lang="en-US" smtClean="0"/>
-              <a:t>8/6/26</a:t>
+              <a:t>9/17/26</a:t>
             </a:fld>
             <a:endParaRPr lang="en-US"/>
           </a:p>
@@ -1977,7 +1977,7 @@
           <a:p>
             <a:fld id="{5BCAD085-E8A6-8845-BD4E-CB4CCA059FC4}" type="datetimeFigureOut">
               <a:rPr lang="en-US" smtClean="0"/>
-              <a:t>8/6/26</a:t>
+              <a:t>9/17/26</a:t>
             </a:fld>
             <a:endParaRPr lang="en-US"/>
           </a:p>
@@ -2252,7 +2252,7 @@
           <a:p>
             <a:fld id="{5BCAD085-E8A6-8845-BD4E-CB4CCA059FC4}" type="datetimeFigureOut">
               <a:rPr lang="en-US" smtClean="0"/>
-              <a:t>8/6/26</a:t>
+              <a:t>9/17/26</a:t>
             </a:fld>
             <a:endParaRPr lang="en-US"/>
           </a:p>
@@ -2504,7 +2504,7 @@
           <a:p>
             <a:fld id="{5BCAD085-E8A6-8845-BD4E-CB4CCA059FC4}" type="datetimeFigureOut">
               <a:rPr lang="en-US" smtClean="0"/>
-              <a:t>8/6/26</a:t>
+              <a:t>9/17/26</a:t>
             </a:fld>
             <a:endParaRPr lang="en-US"/>
           </a:p>
@@ -2715,7 +2715,7 @@
           <a:p>
             <a:fld id="{5BCAD085-E8A6-8845-BD4E-CB4CCA059FC4}" type="datetimeFigureOut">
               <a:rPr lang="en-US" smtClean="0"/>
-              <a:t>8/6/26</a:t>
+              <a:t>9/17/26</a:t>
             </a:fld>
             <a:endParaRPr lang="en-US"/>
           </a:p>
@@ -3304,7 +3304,7 @@
           <a:p>
             <a:pPr algn="l"/>
             <a:r>
-              <a:rPr sz="760" b="0" i="1">
+              <a:rPr sz="760" b="0" i="1" dirty="0">
                 <a:solidFill>
                   <a:srgbClr val="8C8C99"/>
                 </a:solidFill>
@@ -3662,8 +3662,8 @@
         </p:nvSpPr>
         <p:spPr>
           <a:xfrm>
-            <a:off x="4617720" y="2322576"/>
-            <a:ext cx="3776472" cy="201168"/>
+            <a:off x="5883189" y="2322576"/>
+            <a:ext cx="1245534" cy="172355"/>
           </a:xfrm>
           <a:prstGeom prst="rect">
             <a:avLst/>
@@ -3678,13 +3678,22 @@
           <a:p>
             <a:pPr algn="ctr"/>
             <a:r>
-              <a:rPr sz="1120" b="1" i="0">
+              <a:rPr lang="en-US" sz="1120" b="1" dirty="0">
                 <a:solidFill>
                   <a:srgbClr val="0F6E56"/>
                 </a:solidFill>
                 <a:latin typeface="Calibri"/>
               </a:rPr>
-              <a:t>6 elected Developers</a:t>
+              <a:t>4</a:t>
+            </a:r>
+            <a:r>
+              <a:rPr sz="1120" b="1" i="0" dirty="0">
+                <a:solidFill>
+                  <a:srgbClr val="0F6E56"/>
+                </a:solidFill>
+                <a:latin typeface="Calibri"/>
+              </a:rPr>
+              <a:t> elected Developers</a:t>
             </a:r>
           </a:p>
         </p:txBody>
@@ -3940,8 +3949,8 @@
         </p:nvSpPr>
         <p:spPr>
           <a:xfrm>
-            <a:off x="4462272" y="3584448"/>
-            <a:ext cx="4087368" cy="164592"/>
+            <a:off x="5725293" y="3584448"/>
+            <a:ext cx="1561326" cy="138499"/>
           </a:xfrm>
           <a:prstGeom prst="rect">
             <a:avLst/>
@@ -3956,13 +3965,22 @@
           <a:p>
             <a:pPr algn="ctr"/>
             <a:r>
-              <a:rPr sz="900" b="0" i="0">
+              <a:rPr lang="en-US" sz="900" dirty="0">
                 <a:solidFill>
                   <a:srgbClr val="534AB7"/>
                 </a:solidFill>
                 <a:latin typeface="Calibri"/>
               </a:rPr>
-              <a:t>7 voting members · majority vote</a:t>
+              <a:t>5</a:t>
+            </a:r>
+            <a:r>
+              <a:rPr sz="900" b="0" i="0" dirty="0">
+                <a:solidFill>
+                  <a:srgbClr val="534AB7"/>
+                </a:solidFill>
+                <a:latin typeface="Calibri"/>
+              </a:rPr>
+              <a:t> voting members · majority vote</a:t>
             </a:r>
           </a:p>
         </p:txBody>
@@ -4251,7 +4269,7 @@
             <a:noFill/>
             <a:ln w="22860">
               <a:solidFill>
-                <a:srgbClr val="534AB7"/>
+                <a:schemeClr val="tx1"/>
               </a:solidFill>
             </a:ln>
             <a:effectLst/>
@@ -4299,7 +4317,7 @@
             <a:noFill/>
             <a:ln w="22860">
               <a:solidFill>
-                <a:srgbClr val="993C1D"/>
+                <a:schemeClr val="tx1"/>
               </a:solidFill>
             </a:ln>
             <a:effectLst/>
@@ -4421,13 +4439,22 @@
             <a:p>
               <a:pPr algn="l"/>
               <a:r>
+                <a:rPr sz="900" b="0" i="0" dirty="0">
+                  <a:solidFill>
+                    <a:srgbClr val="1A1A1A"/>
+                  </a:solidFill>
+                  <a:latin typeface="Calibri"/>
+                </a:rPr>
+                <a:t>•  providing resources to developers (compute, software</a:t>
+              </a:r>
+              <a:r>
                 <a:rPr sz="900" b="0" i="0">
                   <a:solidFill>
                     <a:srgbClr val="1A1A1A"/>
                   </a:solidFill>
                   <a:latin typeface="Calibri"/>
                 </a:rPr>
-                <a:t>•  providing resources to developers (compute, software, </a:t>
+                <a:t>, </a:t>
               </a:r>
               <a:r>
                 <a:rPr sz="900" b="0" i="1">
@@ -4437,6 +4464,15 @@
                   <a:latin typeface="Calibri"/>
                 </a:rPr>
                 <a:t>etc</a:t>
+              </a:r>
+              <a:r>
+                <a:rPr lang="en-US" sz="900" b="0" i="1">
+                  <a:solidFill>
+                    <a:srgbClr val="1A1A1A"/>
+                  </a:solidFill>
+                  <a:latin typeface="Calibri"/>
+                </a:rPr>
+                <a:t>.</a:t>
               </a:r>
               <a:r>
                 <a:rPr sz="900" b="0" i="0">
@@ -4847,4 +4883,26 @@
   </a:objectDefaults>
   <a:extraClrSchemeLst/>
 </a:theme>
+</file>
+
+<file path=ppt/webextensions/taskpanes.xml><?xml version="1.0" encoding="utf-8"?>
+<wetp:taskpanes xmlns:wetp="http://schemas.microsoft.com/office/webextensions/taskpanes/2010/11">
+  <wetp:taskpane dockstate="right" visibility="0" width="350" row="0">
+    <wetp:webextensionref xmlns:r="http://schemas.openxmlformats.org/officeDocument/2006/relationships" r:id="rId1"/>
+  </wetp:taskpane>
+</wetp:taskpanes>
+</file>
+
+<file path=ppt/webextensions/webextension1.xml><?xml version="1.0" encoding="utf-8"?>
+<we:webextension xmlns:we="http://schemas.microsoft.com/office/webextensions/webextension/2010/11" id="{F7013D85-779B-7545-9BCE-4629E1B961CA}">
+  <we:reference id="wa200010001" version="1.0.0.1" store="en-US" storeType="OMEX"/>
+  <we:alternateReferences>
+    <we:reference id="wa200010001" version="1.0.0.1" store="" storeType="OMEX"/>
+  </we:alternateReferences>
+  <we:properties>
+    <we:property name="claude.fileId" value="&quot;19f5190d-171f-415e-a305-3e79c888dfa9&quot;"/>
+  </we:properties>
+  <we:bindings/>
+  <we:snapshot xmlns:r="http://schemas.openxmlformats.org/officeDocument/2006/relationships"/>
+</we:webextension>
 </file>
</xml_diff>